<commit_message>
Refactor RAGPipeline to clean up LLM sources and ensure correct citation formatting in final answers
</commit_message>
<xml_diff>
--- a/apresentacao_projeto.pptx
+++ b/apresentacao_projeto.pptx
@@ -5,7 +5,7 @@
     <p:sldMasterId id="2147483648" r:id="rId1"/>
   </p:sldMasterIdLst>
   <p:notesMasterIdLst>
-    <p:notesMasterId r:id="rId8"/>
+    <p:notesMasterId r:id="rId9"/>
   </p:notesMasterIdLst>
   <p:sldIdLst>
     <p:sldId id="256" r:id="rId2"/>
@@ -14,6 +14,7 @@
     <p:sldId id="259" r:id="rId5"/>
     <p:sldId id="261" r:id="rId6"/>
     <p:sldId id="260" r:id="rId7"/>
+    <p:sldId id="262" r:id="rId8"/>
   </p:sldIdLst>
   <p:sldSz cx="12192000" cy="6858000"/>
   <p:notesSz cx="6858000" cy="9144000"/>
@@ -112,6 +113,11 @@
       </a:defRPr>
     </a:lvl9pPr>
   </p:defaultTextStyle>
+  <p:extLst>
+    <p:ext uri="{EFAFB233-063F-42B5-8137-9DF3F51BA10A}">
+      <p15:sldGuideLst xmlns:p15="http://schemas.microsoft.com/office/powerpoint/2012/main"/>
+    </p:ext>
+  </p:extLst>
 </p:presentation>
 </file>
 
@@ -492,6 +498,13 @@
           </p:nvPr>
         </p:nvSpPr>
         <p:spPr/>
+        <p:txBody>
+          <a:bodyPr/>
+          <a:lstStyle/>
+          <a:p>
+            <a:endParaRPr lang="pt-BR"/>
+          </a:p>
+        </p:txBody>
       </p:sp>
       <p:sp>
         <p:nvSpPr>
@@ -3833,7 +3846,7 @@
           <a:p>
             <a:pPr algn="ctr"/>
             <a:r>
-              <a:rPr lang="pt-BR" sz="8800" b="1" dirty="0" err="1">
+              <a:rPr lang="pt-BR" sz="8800" b="1" dirty="0">
                 <a:solidFill>
                   <a:srgbClr val="ED145B"/>
                 </a:solidFill>
@@ -3842,13 +3855,6 @@
               </a:rPr>
               <a:t>OncoSUS</a:t>
             </a:r>
-            <a:endParaRPr lang="pt-BR" sz="8800" b="1" dirty="0">
-              <a:solidFill>
-                <a:srgbClr val="ED145B"/>
-              </a:solidFill>
-              <a:ea typeface="Calibri" panose="020F0502020204030204" pitchFamily="34" charset="0"/>
-              <a:cs typeface="Cascadia Code ExtraLight" panose="020B0609020000020004" pitchFamily="49" charset="0"/>
-            </a:endParaRPr>
           </a:p>
         </p:txBody>
       </p:sp>
@@ -4275,7 +4281,7 @@
           <a:lstStyle/>
           <a:p>
             <a:r>
-              <a:rPr lang="pt-BR" sz="3600" b="1" dirty="0" err="1">
+              <a:rPr lang="pt-BR" sz="3600" b="1" dirty="0">
                 <a:solidFill>
                   <a:srgbClr val="ED145B"/>
                 </a:solidFill>
@@ -4284,13 +4290,6 @@
               </a:rPr>
               <a:t>OncoSUS</a:t>
             </a:r>
-            <a:endParaRPr lang="pt-BR" sz="3600" b="1" dirty="0">
-              <a:solidFill>
-                <a:srgbClr val="ED145B"/>
-              </a:solidFill>
-              <a:ea typeface="Calibri" panose="020F0502020204030204" pitchFamily="34" charset="0"/>
-              <a:cs typeface="Cascadia Code ExtraLight" panose="020B0609020000020004" pitchFamily="49" charset="0"/>
-            </a:endParaRPr>
           </a:p>
         </p:txBody>
       </p:sp>
@@ -4309,7 +4308,7 @@
         <p:spPr>
           <a:xfrm>
             <a:off x="710253" y="3251993"/>
-            <a:ext cx="4698787" cy="1754326"/>
+            <a:ext cx="4698787" cy="1477328"/>
           </a:xfrm>
           <a:prstGeom prst="rect">
             <a:avLst/>
@@ -4386,17 +4385,6 @@
               </a:rPr>
               <a:t>Gustavo Paulino – RM369057</a:t>
             </a:r>
-          </a:p>
-          <a:p>
-            <a:pPr marL="742950" lvl="1" indent="-285750">
-              <a:buFont typeface="Arial" panose="020B0604020202020204" pitchFamily="34" charset="0"/>
-              <a:buChar char="•"/>
-            </a:pPr>
-            <a:endParaRPr lang="pt-BR" dirty="0">
-              <a:solidFill>
-                <a:schemeClr val="bg1"/>
-              </a:solidFill>
-            </a:endParaRPr>
           </a:p>
         </p:txBody>
       </p:sp>
@@ -4590,7 +4578,7 @@
         </p:nvSpPr>
         <p:spPr>
           <a:xfrm>
-            <a:off x="2338901" y="1495388"/>
+            <a:off x="2063598" y="1607858"/>
             <a:ext cx="1778051" cy="1107996"/>
           </a:xfrm>
           <a:prstGeom prst="rect">
@@ -4715,7 +4703,7 @@
         </p:nvSpPr>
         <p:spPr>
           <a:xfrm>
-            <a:off x="1849047" y="2383350"/>
+            <a:off x="1573744" y="2495820"/>
             <a:ext cx="2757757" cy="954107"/>
           </a:xfrm>
           <a:prstGeom prst="rect">
@@ -4755,7 +4743,7 @@
         </p:nvSpPr>
         <p:spPr>
           <a:xfrm>
-            <a:off x="6773139" y="1906296"/>
+            <a:off x="6497836" y="2018766"/>
             <a:ext cx="3775858" cy="954107"/>
           </a:xfrm>
           <a:prstGeom prst="rect">
@@ -4795,8 +4783,8 @@
         </p:nvSpPr>
         <p:spPr>
           <a:xfrm>
-            <a:off x="5304879" y="2012523"/>
-            <a:ext cx="978408" cy="741651"/>
+            <a:off x="4699820" y="2178098"/>
+            <a:ext cx="1308164" cy="590861"/>
           </a:xfrm>
           <a:prstGeom prst="rightArrow">
             <a:avLst/>
@@ -4849,7 +4837,7 @@
         </p:nvSpPr>
         <p:spPr>
           <a:xfrm>
-            <a:off x="6453286" y="4227299"/>
+            <a:off x="3841649" y="4436643"/>
             <a:ext cx="4415561" cy="954107"/>
           </a:xfrm>
           <a:prstGeom prst="rect">
@@ -4888,9 +4876,9 @@
           <p:nvPr/>
         </p:nvSpPr>
         <p:spPr>
-          <a:xfrm rot="5400000">
-            <a:off x="8171863" y="3321435"/>
-            <a:ext cx="978408" cy="444832"/>
+          <a:xfrm rot="6730303">
+            <a:off x="6062833" y="3454576"/>
+            <a:ext cx="1271095" cy="444832"/>
           </a:xfrm>
           <a:prstGeom prst="rightArrow">
             <a:avLst/>
@@ -5035,6 +5023,57 @@
               </a:rPr>
               <a:t>7IADT – Fase 3</a:t>
             </a:r>
+          </a:p>
+        </p:txBody>
+      </p:sp>
+      <p:sp>
+        <p:nvSpPr>
+          <p:cNvPr id="10" name="CaixaDeTexto 9">
+            <a:extLst>
+              <a:ext uri="{FF2B5EF4-FFF2-40B4-BE49-F238E27FC236}">
+                <a16:creationId xmlns:a16="http://schemas.microsoft.com/office/drawing/2014/main" id="{A6D7BE2C-9AA8-F79A-80E8-CFEF1AA96045}"/>
+              </a:ext>
+            </a:extLst>
+          </p:cNvPr>
+          <p:cNvSpPr txBox="1"/>
+          <p:nvPr/>
+        </p:nvSpPr>
+        <p:spPr>
+          <a:xfrm>
+            <a:off x="7485805" y="2877920"/>
+            <a:ext cx="1799916" cy="307777"/>
+          </a:xfrm>
+          <a:prstGeom prst="rect">
+            <a:avLst/>
+          </a:prstGeom>
+          <a:noFill/>
+        </p:spPr>
+        <p:txBody>
+          <a:bodyPr wrap="none" rtlCol="0">
+            <a:spAutoFit/>
+          </a:bodyPr>
+          <a:lstStyle/>
+          <a:p>
+            <a:r>
+              <a:rPr lang="pt-BR" sz="1400" dirty="0">
+                <a:solidFill>
+                  <a:schemeClr val="bg1"/>
+                </a:solidFill>
+                <a:hlinkClick r:id="rId4">
+                  <a:extLst>
+                    <a:ext uri="{A12FA001-AC4F-418D-AE19-62706E023703}">
+                      <ahyp:hlinkClr xmlns:ahyp="http://schemas.microsoft.com/office/drawing/2018/hyperlinkcolor" val="tx"/>
+                    </a:ext>
+                  </a:extLst>
+                </a:hlinkClick>
+              </a:rPr>
+              <a:t>Ver mais sobre PCDT</a:t>
+            </a:r>
+            <a:endParaRPr lang="pt-BR" sz="1400" dirty="0">
+              <a:solidFill>
+                <a:schemeClr val="bg1"/>
+              </a:solidFill>
+            </a:endParaRPr>
           </a:p>
         </p:txBody>
       </p:sp>
@@ -5606,7 +5645,7 @@
           <a:lstStyle/>
           <a:p>
             <a:r>
-              <a:rPr lang="pt-BR" sz="4400" b="1" dirty="0" err="1">
+              <a:rPr lang="pt-BR" sz="4400" b="1" dirty="0">
                 <a:solidFill>
                   <a:srgbClr val="ED145B"/>
                 </a:solidFill>
@@ -5615,13 +5654,6 @@
               </a:rPr>
               <a:t>OncoSUS</a:t>
             </a:r>
-            <a:endParaRPr lang="pt-BR" sz="4400" b="1" dirty="0">
-              <a:solidFill>
-                <a:srgbClr val="ED145B"/>
-              </a:solidFill>
-              <a:ea typeface="Calibri" panose="020F0502020204030204" pitchFamily="34" charset="0"/>
-              <a:cs typeface="Cascadia Code ExtraLight" panose="020B0609020000020004" pitchFamily="49" charset="0"/>
-            </a:endParaRPr>
           </a:p>
         </p:txBody>
       </p:sp>
@@ -6137,18 +6169,13 @@
           <a:p>
             <a:pPr algn="ctr"/>
             <a:r>
-              <a:rPr lang="pt-BR" sz="2000" b="1" dirty="0" err="1">
+              <a:rPr lang="pt-BR" sz="2000" b="1" dirty="0">
                 <a:solidFill>
                   <a:schemeClr val="bg1"/>
                 </a:solidFill>
               </a:rPr>
               <a:t>OncoSUS</a:t>
             </a:r>
-            <a:endParaRPr lang="pt-BR" sz="2000" b="1" dirty="0">
-              <a:solidFill>
-                <a:schemeClr val="bg1"/>
-              </a:solidFill>
-            </a:endParaRPr>
           </a:p>
         </p:txBody>
       </p:sp>
@@ -7302,7 +7329,7 @@
         </p:nvSpPr>
         <p:spPr>
           <a:xfrm>
-            <a:off x="8100779" y="3797300"/>
+            <a:off x="7029063" y="3760019"/>
             <a:ext cx="2476500" cy="1440000"/>
           </a:xfrm>
           <a:prstGeom prst="roundRect">
@@ -7348,25 +7375,21 @@
                 <a:ea typeface="Calibri" panose="020F0502020204030204" pitchFamily="34" charset="0"/>
                 <a:cs typeface="Cascadia Code ExtraLight" panose="020B0609020000020004" pitchFamily="49" charset="0"/>
               </a:rPr>
-              <a:t>4. Criação do RAG + Fine-</a:t>
-            </a:r>
-            <a:r>
-              <a:rPr lang="pt-BR" b="1" dirty="0" err="1">
+              <a:t>4. Criação </a:t>
+            </a:r>
+          </a:p>
+          <a:p>
+            <a:pPr algn="ctr"/>
+            <a:r>
+              <a:rPr lang="pt-BR" b="1" dirty="0">
                 <a:solidFill>
                   <a:srgbClr val="ED145B"/>
                 </a:solidFill>
                 <a:ea typeface="Calibri" panose="020F0502020204030204" pitchFamily="34" charset="0"/>
                 <a:cs typeface="Cascadia Code ExtraLight" panose="020B0609020000020004" pitchFamily="49" charset="0"/>
               </a:rPr>
-              <a:t>Tuning</a:t>
-            </a:r>
-            <a:endParaRPr lang="pt-BR" b="1" dirty="0">
-              <a:solidFill>
-                <a:srgbClr val="ED145B"/>
-              </a:solidFill>
-              <a:ea typeface="Calibri" panose="020F0502020204030204" pitchFamily="34" charset="0"/>
-              <a:cs typeface="Cascadia Code ExtraLight" panose="020B0609020000020004" pitchFamily="49" charset="0"/>
-            </a:endParaRPr>
+              <a:t>do RAG</a:t>
+            </a:r>
           </a:p>
         </p:txBody>
       </p:sp>
@@ -7384,7 +7407,7 @@
         </p:nvSpPr>
         <p:spPr>
           <a:xfrm>
-            <a:off x="4912402" y="3797300"/>
+            <a:off x="3211421" y="3740355"/>
             <a:ext cx="2476500" cy="1440000"/>
           </a:xfrm>
           <a:prstGeom prst="roundRect">
@@ -7431,91 +7454,6 @@
                 <a:cs typeface="Cascadia Code ExtraLight" panose="020B0609020000020004" pitchFamily="49" charset="0"/>
               </a:rPr>
               <a:t>5. Integração com dados sintéticos de pacientes</a:t>
-            </a:r>
-          </a:p>
-        </p:txBody>
-      </p:sp>
-      <p:sp>
-        <p:nvSpPr>
-          <p:cNvPr id="28" name="Retângulo: Cantos Arredondados 27">
-            <a:extLst>
-              <a:ext uri="{FF2B5EF4-FFF2-40B4-BE49-F238E27FC236}">
-                <a16:creationId xmlns:a16="http://schemas.microsoft.com/office/drawing/2014/main" id="{1E862B16-FA6D-1B82-5119-8FD64325C5E7}"/>
-              </a:ext>
-            </a:extLst>
-          </p:cNvPr>
-          <p:cNvSpPr/>
-          <p:nvPr/>
-        </p:nvSpPr>
-        <p:spPr>
-          <a:xfrm>
-            <a:off x="1724025" y="3797302"/>
-            <a:ext cx="2476500" cy="1440000"/>
-          </a:xfrm>
-          <a:prstGeom prst="roundRect">
-            <a:avLst>
-              <a:gd name="adj" fmla="val 9770"/>
-            </a:avLst>
-          </a:prstGeom>
-          <a:solidFill>
-            <a:schemeClr val="bg1">
-              <a:lumMod val="95000"/>
-            </a:schemeClr>
-          </a:solidFill>
-          <a:ln>
-            <a:noFill/>
-          </a:ln>
-        </p:spPr>
-        <p:style>
-          <a:lnRef idx="2">
-            <a:schemeClr val="accent1">
-              <a:shade val="15000"/>
-            </a:schemeClr>
-          </a:lnRef>
-          <a:fillRef idx="1">
-            <a:schemeClr val="accent1"/>
-          </a:fillRef>
-          <a:effectRef idx="0">
-            <a:schemeClr val="accent1"/>
-          </a:effectRef>
-          <a:fontRef idx="minor">
-            <a:schemeClr val="lt1"/>
-          </a:fontRef>
-        </p:style>
-        <p:txBody>
-          <a:bodyPr rtlCol="0" anchor="ctr"/>
-          <a:lstStyle/>
-          <a:p>
-            <a:pPr algn="ctr"/>
-            <a:r>
-              <a:rPr lang="pt-BR" b="1" dirty="0">
-                <a:solidFill>
-                  <a:srgbClr val="ED145B"/>
-                </a:solidFill>
-                <a:ea typeface="Calibri" panose="020F0502020204030204" pitchFamily="34" charset="0"/>
-                <a:cs typeface="Cascadia Code ExtraLight" panose="020B0609020000020004" pitchFamily="49" charset="0"/>
-              </a:rPr>
-              <a:t>6. Integração com API e </a:t>
-            </a:r>
-            <a:r>
-              <a:rPr lang="pt-BR" b="1" dirty="0" err="1">
-                <a:solidFill>
-                  <a:srgbClr val="ED145B"/>
-                </a:solidFill>
-                <a:ea typeface="Calibri" panose="020F0502020204030204" pitchFamily="34" charset="0"/>
-                <a:cs typeface="Cascadia Code ExtraLight" panose="020B0609020000020004" pitchFamily="49" charset="0"/>
-              </a:rPr>
-              <a:t>frontend</a:t>
-            </a:r>
-            <a:r>
-              <a:rPr lang="pt-BR" b="1" dirty="0">
-                <a:solidFill>
-                  <a:srgbClr val="ED145B"/>
-                </a:solidFill>
-                <a:ea typeface="Calibri" panose="020F0502020204030204" pitchFamily="34" charset="0"/>
-                <a:cs typeface="Cascadia Code ExtraLight" panose="020B0609020000020004" pitchFamily="49" charset="0"/>
-              </a:rPr>
-              <a:t> para utilização por usuários</a:t>
             </a:r>
           </a:p>
         </p:txBody>
@@ -7614,24 +7552,24 @@
       </p:cxnSp>
       <p:cxnSp>
         <p:nvCxnSpPr>
-          <p:cNvPr id="39" name="Conector de Seta Reta 38">
-            <a:extLst>
-              <a:ext uri="{FF2B5EF4-FFF2-40B4-BE49-F238E27FC236}">
-                <a16:creationId xmlns:a16="http://schemas.microsoft.com/office/drawing/2014/main" id="{C30F8DDF-D187-044B-19EC-8BB24482E49E}"/>
+          <p:cNvPr id="42" name="Conector de Seta Reta 41">
+            <a:extLst>
+              <a:ext uri="{FF2B5EF4-FFF2-40B4-BE49-F238E27FC236}">
+                <a16:creationId xmlns:a16="http://schemas.microsoft.com/office/drawing/2014/main" id="{58C90801-F064-9644-7E07-75F656DDBFE7}"/>
               </a:ext>
             </a:extLst>
           </p:cNvPr>
           <p:cNvCxnSpPr>
             <a:cxnSpLocks/>
-            <a:stCxn id="25" idx="2"/>
-            <a:endCxn id="26" idx="0"/>
+            <a:stCxn id="26" idx="1"/>
+            <a:endCxn id="27" idx="3"/>
           </p:cNvCxnSpPr>
           <p:nvPr/>
         </p:nvCxnSpPr>
         <p:spPr>
-          <a:xfrm>
-            <a:off x="9339029" y="3172556"/>
-            <a:ext cx="0" cy="624744"/>
+          <a:xfrm flipH="1" flipV="1">
+            <a:off x="5687921" y="4460355"/>
+            <a:ext cx="1341142" cy="19664"/>
           </a:xfrm>
           <a:prstGeom prst="straightConnector1">
             <a:avLst/>
@@ -7660,73 +7598,29 @@
       </p:cxnSp>
       <p:cxnSp>
         <p:nvCxnSpPr>
-          <p:cNvPr id="42" name="Conector de Seta Reta 41">
-            <a:extLst>
-              <a:ext uri="{FF2B5EF4-FFF2-40B4-BE49-F238E27FC236}">
-                <a16:creationId xmlns:a16="http://schemas.microsoft.com/office/drawing/2014/main" id="{58C90801-F064-9644-7E07-75F656DDBFE7}"/>
+          <p:cNvPr id="7" name="Conector: Angulado 6">
+            <a:extLst>
+              <a:ext uri="{FF2B5EF4-FFF2-40B4-BE49-F238E27FC236}">
+                <a16:creationId xmlns:a16="http://schemas.microsoft.com/office/drawing/2014/main" id="{DCDD88FE-D4A2-6BB5-13A6-65522D243DEC}"/>
               </a:ext>
             </a:extLst>
           </p:cNvPr>
           <p:cNvCxnSpPr>
             <a:cxnSpLocks/>
-            <a:stCxn id="26" idx="1"/>
-            <a:endCxn id="27" idx="3"/>
+            <a:stCxn id="25" idx="2"/>
+            <a:endCxn id="26" idx="0"/>
           </p:cNvCxnSpPr>
           <p:nvPr/>
         </p:nvCxnSpPr>
         <p:spPr>
-          <a:xfrm flipH="1">
-            <a:off x="7388902" y="4517300"/>
-            <a:ext cx="711877" cy="0"/>
-          </a:xfrm>
-          <a:prstGeom prst="straightConnector1">
-            <a:avLst/>
-          </a:prstGeom>
-          <a:ln w="38100">
-            <a:solidFill>
-              <a:srgbClr val="ED145B"/>
-            </a:solidFill>
-            <a:tailEnd type="triangle"/>
-          </a:ln>
-        </p:spPr>
-        <p:style>
-          <a:lnRef idx="2">
-            <a:schemeClr val="accent1"/>
-          </a:lnRef>
-          <a:fillRef idx="0">
-            <a:schemeClr val="accent1"/>
-          </a:fillRef>
-          <a:effectRef idx="1">
-            <a:schemeClr val="accent1"/>
-          </a:effectRef>
-          <a:fontRef idx="minor">
-            <a:schemeClr val="tx1"/>
-          </a:fontRef>
-        </p:style>
-      </p:cxnSp>
-      <p:cxnSp>
-        <p:nvCxnSpPr>
-          <p:cNvPr id="45" name="Conector de Seta Reta 44">
-            <a:extLst>
-              <a:ext uri="{FF2B5EF4-FFF2-40B4-BE49-F238E27FC236}">
-                <a16:creationId xmlns:a16="http://schemas.microsoft.com/office/drawing/2014/main" id="{B232BF37-DA8F-039C-0931-E266981DF0DF}"/>
-              </a:ext>
-            </a:extLst>
-          </p:cNvPr>
-          <p:cNvCxnSpPr>
-            <a:cxnSpLocks/>
-            <a:stCxn id="27" idx="1"/>
-            <a:endCxn id="28" idx="3"/>
-          </p:cNvCxnSpPr>
-          <p:nvPr/>
-        </p:nvCxnSpPr>
-        <p:spPr>
-          <a:xfrm flipH="1">
-            <a:off x="4200525" y="4517300"/>
-            <a:ext cx="711877" cy="2"/>
-          </a:xfrm>
-          <a:prstGeom prst="straightConnector1">
-            <a:avLst/>
+          <a:xfrm rot="5400000">
+            <a:off x="8509440" y="2930429"/>
+            <a:ext cx="587463" cy="1071716"/>
+          </a:xfrm>
+          <a:prstGeom prst="bentConnector3">
+            <a:avLst>
+              <a:gd name="adj1" fmla="val 50000"/>
+            </a:avLst>
           </a:prstGeom>
           <a:ln w="38100">
             <a:solidFill>
@@ -7754,6 +7648,713 @@
     <p:extLst>
       <p:ext uri="{BB962C8B-B14F-4D97-AF65-F5344CB8AC3E}">
         <p14:creationId xmlns:p14="http://schemas.microsoft.com/office/powerpoint/2010/main" val="3102482568"/>
+      </p:ext>
+    </p:extLst>
+  </p:cSld>
+  <p:clrMapOvr>
+    <a:masterClrMapping/>
+  </p:clrMapOvr>
+</p:sld>
+</file>
+
+<file path=ppt/slides/slide7.xml><?xml version="1.0" encoding="utf-8"?>
+<p:sld xmlns:a="http://schemas.openxmlformats.org/drawingml/2006/main" xmlns:r="http://schemas.openxmlformats.org/officeDocument/2006/relationships" xmlns:p="http://schemas.openxmlformats.org/presentationml/2006/main">
+  <p:cSld>
+    <p:spTree>
+      <p:nvGrpSpPr>
+        <p:cNvPr id="1" name="">
+          <a:extLst>
+            <a:ext uri="{FF2B5EF4-FFF2-40B4-BE49-F238E27FC236}">
+              <a16:creationId xmlns:a16="http://schemas.microsoft.com/office/drawing/2014/main" id="{0BF79BC6-880C-5ED5-A889-1C0C1D284E41}"/>
+            </a:ext>
+          </a:extLst>
+        </p:cNvPr>
+        <p:cNvGrpSpPr/>
+        <p:nvPr/>
+      </p:nvGrpSpPr>
+      <p:grpSpPr>
+        <a:xfrm>
+          <a:off x="0" y="0"/>
+          <a:ext cx="0" cy="0"/>
+          <a:chOff x="0" y="0"/>
+          <a:chExt cx="0" cy="0"/>
+        </a:xfrm>
+      </p:grpSpPr>
+      <p:pic>
+        <p:nvPicPr>
+          <p:cNvPr id="2" name="Imagem 1">
+            <a:extLst>
+              <a:ext uri="{FF2B5EF4-FFF2-40B4-BE49-F238E27FC236}">
+                <a16:creationId xmlns:a16="http://schemas.microsoft.com/office/drawing/2014/main" id="{DFF351B0-DB78-253E-4126-DB962A1DF5AA}"/>
+              </a:ext>
+            </a:extLst>
+          </p:cNvPr>
+          <p:cNvPicPr>
+            <a:picLocks noChangeAspect="1"/>
+          </p:cNvPicPr>
+          <p:nvPr/>
+        </p:nvPicPr>
+        <p:blipFill>
+          <a:blip r:embed="rId2">
+            <a:extLst>
+              <a:ext uri="{28A0092B-C50C-407E-A947-70E740481C1C}">
+                <a14:useLocalDpi xmlns:a14="http://schemas.microsoft.com/office/drawing/2010/main" val="0"/>
+              </a:ext>
+            </a:extLst>
+          </a:blip>
+          <a:stretch>
+            <a:fillRect/>
+          </a:stretch>
+        </p:blipFill>
+        <p:spPr>
+          <a:xfrm>
+            <a:off x="0" y="0"/>
+            <a:ext cx="12192000" cy="6858000"/>
+          </a:xfrm>
+          <a:prstGeom prst="rect">
+            <a:avLst/>
+          </a:prstGeom>
+        </p:spPr>
+      </p:pic>
+      <p:pic>
+        <p:nvPicPr>
+          <p:cNvPr id="18" name="Picture 2" descr="FIAPP – Apps no Google Play">
+            <a:extLst>
+              <a:ext uri="{FF2B5EF4-FFF2-40B4-BE49-F238E27FC236}">
+                <a16:creationId xmlns:a16="http://schemas.microsoft.com/office/drawing/2014/main" id="{21A92C17-FB78-2969-E24E-50BBAB9B8900}"/>
+              </a:ext>
+            </a:extLst>
+          </p:cNvPr>
+          <p:cNvPicPr>
+            <a:picLocks noChangeAspect="1" noChangeArrowheads="1"/>
+          </p:cNvPicPr>
+          <p:nvPr/>
+        </p:nvPicPr>
+        <p:blipFill>
+          <a:blip r:embed="rId3">
+            <a:extLst>
+              <a:ext uri="{28A0092B-C50C-407E-A947-70E740481C1C}">
+                <a14:useLocalDpi xmlns:a14="http://schemas.microsoft.com/office/drawing/2010/main" val="0"/>
+              </a:ext>
+            </a:extLst>
+          </a:blip>
+          <a:srcRect/>
+          <a:stretch>
+            <a:fillRect/>
+          </a:stretch>
+        </p:blipFill>
+        <p:spPr bwMode="auto">
+          <a:xfrm>
+            <a:off x="303228" y="6146800"/>
+            <a:ext cx="407025" cy="407025"/>
+          </a:xfrm>
+          <a:prstGeom prst="rect">
+            <a:avLst/>
+          </a:prstGeom>
+          <a:noFill/>
+          <a:extLst>
+            <a:ext uri="{909E8E84-426E-40DD-AFC4-6F175D3DCCD1}">
+              <a14:hiddenFill xmlns:a14="http://schemas.microsoft.com/office/drawing/2010/main">
+                <a:solidFill>
+                  <a:srgbClr val="FFFFFF"/>
+                </a:solidFill>
+              </a14:hiddenFill>
+            </a:ext>
+          </a:extLst>
+        </p:spPr>
+      </p:pic>
+      <p:sp>
+        <p:nvSpPr>
+          <p:cNvPr id="19" name="CaixaDeTexto 18">
+            <a:extLst>
+              <a:ext uri="{FF2B5EF4-FFF2-40B4-BE49-F238E27FC236}">
+                <a16:creationId xmlns:a16="http://schemas.microsoft.com/office/drawing/2014/main" id="{9F8156DE-EFEB-A37A-5F3B-D84A778D70F7}"/>
+              </a:ext>
+            </a:extLst>
+          </p:cNvPr>
+          <p:cNvSpPr txBox="1"/>
+          <p:nvPr/>
+        </p:nvSpPr>
+        <p:spPr>
+          <a:xfrm>
+            <a:off x="710253" y="6146800"/>
+            <a:ext cx="1422184" cy="430887"/>
+          </a:xfrm>
+          <a:prstGeom prst="rect">
+            <a:avLst/>
+          </a:prstGeom>
+          <a:noFill/>
+        </p:spPr>
+        <p:txBody>
+          <a:bodyPr wrap="none" rtlCol="0">
+            <a:spAutoFit/>
+          </a:bodyPr>
+          <a:lstStyle/>
+          <a:p>
+            <a:r>
+              <a:rPr lang="pt-BR" sz="1100" dirty="0">
+                <a:solidFill>
+                  <a:schemeClr val="bg1"/>
+                </a:solidFill>
+              </a:rPr>
+              <a:t>Pós em IA para </a:t>
+            </a:r>
+            <a:r>
+              <a:rPr lang="pt-BR" sz="1100" dirty="0" err="1">
+                <a:solidFill>
+                  <a:schemeClr val="bg1"/>
+                </a:solidFill>
+              </a:rPr>
+              <a:t>Devs</a:t>
+            </a:r>
+            <a:endParaRPr lang="pt-BR" sz="1100" dirty="0">
+              <a:solidFill>
+                <a:schemeClr val="bg1"/>
+              </a:solidFill>
+            </a:endParaRPr>
+          </a:p>
+          <a:p>
+            <a:r>
+              <a:rPr lang="pt-BR" sz="1100" dirty="0">
+                <a:solidFill>
+                  <a:schemeClr val="bg1"/>
+                </a:solidFill>
+              </a:rPr>
+              <a:t>7IADT – Fase 3</a:t>
+            </a:r>
+          </a:p>
+        </p:txBody>
+      </p:sp>
+      <p:sp>
+        <p:nvSpPr>
+          <p:cNvPr id="20" name="CaixaDeTexto 19">
+            <a:extLst>
+              <a:ext uri="{FF2B5EF4-FFF2-40B4-BE49-F238E27FC236}">
+                <a16:creationId xmlns:a16="http://schemas.microsoft.com/office/drawing/2014/main" id="{5D738FC5-1DEF-9BB5-62ED-8F5D16AE2084}"/>
+              </a:ext>
+            </a:extLst>
+          </p:cNvPr>
+          <p:cNvSpPr txBox="1"/>
+          <p:nvPr/>
+        </p:nvSpPr>
+        <p:spPr>
+          <a:xfrm>
+            <a:off x="303228" y="390142"/>
+            <a:ext cx="660220" cy="461665"/>
+          </a:xfrm>
+          <a:prstGeom prst="rect">
+            <a:avLst/>
+          </a:prstGeom>
+          <a:solidFill>
+            <a:srgbClr val="ED145B"/>
+          </a:solidFill>
+        </p:spPr>
+        <p:txBody>
+          <a:bodyPr wrap="square" rtlCol="0">
+            <a:spAutoFit/>
+          </a:bodyPr>
+          <a:lstStyle/>
+          <a:p>
+            <a:pPr algn="ctr"/>
+            <a:r>
+              <a:rPr lang="pt-BR" sz="2400" b="1" dirty="0">
+                <a:solidFill>
+                  <a:schemeClr val="bg1"/>
+                </a:solidFill>
+              </a:rPr>
+              <a:t>5</a:t>
+            </a:r>
+          </a:p>
+        </p:txBody>
+      </p:sp>
+      <p:sp>
+        <p:nvSpPr>
+          <p:cNvPr id="21" name="CaixaDeTexto 20">
+            <a:extLst>
+              <a:ext uri="{FF2B5EF4-FFF2-40B4-BE49-F238E27FC236}">
+                <a16:creationId xmlns:a16="http://schemas.microsoft.com/office/drawing/2014/main" id="{D49C8425-FDFB-FB5F-9C2A-318538892BAC}"/>
+              </a:ext>
+            </a:extLst>
+          </p:cNvPr>
+          <p:cNvSpPr txBox="1"/>
+          <p:nvPr/>
+        </p:nvSpPr>
+        <p:spPr>
+          <a:xfrm>
+            <a:off x="963448" y="364742"/>
+            <a:ext cx="6715546" cy="523220"/>
+          </a:xfrm>
+          <a:prstGeom prst="rect">
+            <a:avLst/>
+          </a:prstGeom>
+          <a:noFill/>
+        </p:spPr>
+        <p:txBody>
+          <a:bodyPr wrap="square" rtlCol="0">
+            <a:spAutoFit/>
+          </a:bodyPr>
+          <a:lstStyle/>
+          <a:p>
+            <a:r>
+              <a:rPr lang="pt-BR" sz="2800" b="1" dirty="0">
+                <a:solidFill>
+                  <a:srgbClr val="ED145B"/>
+                </a:solidFill>
+                <a:ea typeface="Calibri" panose="020F0502020204030204" pitchFamily="34" charset="0"/>
+                <a:cs typeface="Cascadia Code ExtraLight" panose="020B0609020000020004" pitchFamily="49" charset="0"/>
+              </a:rPr>
+              <a:t>Repositórios e scripts no Google Colab</a:t>
+            </a:r>
+          </a:p>
+        </p:txBody>
+      </p:sp>
+      <p:pic>
+        <p:nvPicPr>
+          <p:cNvPr id="6" name="Imagem 5">
+            <a:extLst>
+              <a:ext uri="{FF2B5EF4-FFF2-40B4-BE49-F238E27FC236}">
+                <a16:creationId xmlns:a16="http://schemas.microsoft.com/office/drawing/2014/main" id="{5F767F37-A25E-EEC0-6B2E-1505BC110311}"/>
+              </a:ext>
+            </a:extLst>
+          </p:cNvPr>
+          <p:cNvPicPr>
+            <a:picLocks noChangeAspect="1"/>
+          </p:cNvPicPr>
+          <p:nvPr/>
+        </p:nvPicPr>
+        <p:blipFill>
+          <a:blip r:embed="rId4">
+            <a:extLst>
+              <a:ext uri="{28A0092B-C50C-407E-A947-70E740481C1C}">
+                <a14:useLocalDpi xmlns:a14="http://schemas.microsoft.com/office/drawing/2010/main" val="0"/>
+              </a:ext>
+            </a:extLst>
+          </a:blip>
+          <a:stretch>
+            <a:fillRect/>
+          </a:stretch>
+        </p:blipFill>
+        <p:spPr>
+          <a:xfrm>
+            <a:off x="1258529" y="1414157"/>
+            <a:ext cx="759035" cy="759035"/>
+          </a:xfrm>
+          <a:prstGeom prst="rect">
+            <a:avLst/>
+          </a:prstGeom>
+        </p:spPr>
+      </p:pic>
+      <p:sp>
+        <p:nvSpPr>
+          <p:cNvPr id="8" name="CaixaDeTexto 7">
+            <a:extLst>
+              <a:ext uri="{FF2B5EF4-FFF2-40B4-BE49-F238E27FC236}">
+                <a16:creationId xmlns:a16="http://schemas.microsoft.com/office/drawing/2014/main" id="{3D0878F3-1A18-229F-7226-F1AEEF6FF12B}"/>
+              </a:ext>
+            </a:extLst>
+          </p:cNvPr>
+          <p:cNvSpPr txBox="1"/>
+          <p:nvPr/>
+        </p:nvSpPr>
+        <p:spPr>
+          <a:xfrm>
+            <a:off x="2198113" y="1771029"/>
+            <a:ext cx="4532672" cy="307777"/>
+          </a:xfrm>
+          <a:prstGeom prst="rect">
+            <a:avLst/>
+          </a:prstGeom>
+          <a:noFill/>
+        </p:spPr>
+        <p:txBody>
+          <a:bodyPr wrap="square" rtlCol="0">
+            <a:spAutoFit/>
+          </a:bodyPr>
+          <a:lstStyle/>
+          <a:p>
+            <a:r>
+              <a:rPr lang="pt-BR" sz="1400" dirty="0">
+                <a:solidFill>
+                  <a:schemeClr val="bg1"/>
+                </a:solidFill>
+                <a:hlinkClick r:id="rId5">
+                  <a:extLst>
+                    <a:ext uri="{A12FA001-AC4F-418D-AE19-62706E023703}">
+                      <ahyp:hlinkClr xmlns:ahyp="http://schemas.microsoft.com/office/drawing/2018/hyperlinkcolor" val="tx"/>
+                    </a:ext>
+                  </a:extLst>
+                </a:hlinkClick>
+              </a:rPr>
+              <a:t>https://github.com/allanribeiro91/oncosus</a:t>
+            </a:r>
+            <a:endParaRPr lang="pt-BR" sz="1400" dirty="0">
+              <a:solidFill>
+                <a:schemeClr val="bg1"/>
+              </a:solidFill>
+            </a:endParaRPr>
+          </a:p>
+        </p:txBody>
+      </p:sp>
+      <p:sp>
+        <p:nvSpPr>
+          <p:cNvPr id="9" name="CaixaDeTexto 8">
+            <a:extLst>
+              <a:ext uri="{FF2B5EF4-FFF2-40B4-BE49-F238E27FC236}">
+                <a16:creationId xmlns:a16="http://schemas.microsoft.com/office/drawing/2014/main" id="{DA7BCBB2-60FB-48B7-A668-F98FF5BE3D76}"/>
+              </a:ext>
+            </a:extLst>
+          </p:cNvPr>
+          <p:cNvSpPr txBox="1"/>
+          <p:nvPr/>
+        </p:nvSpPr>
+        <p:spPr>
+          <a:xfrm>
+            <a:off x="2198114" y="1501676"/>
+            <a:ext cx="4532672" cy="400110"/>
+          </a:xfrm>
+          <a:prstGeom prst="rect">
+            <a:avLst/>
+          </a:prstGeom>
+          <a:noFill/>
+        </p:spPr>
+        <p:txBody>
+          <a:bodyPr wrap="square" rtlCol="0">
+            <a:spAutoFit/>
+          </a:bodyPr>
+          <a:lstStyle/>
+          <a:p>
+            <a:r>
+              <a:rPr lang="pt-BR" sz="2000" b="1" dirty="0">
+                <a:solidFill>
+                  <a:schemeClr val="bg1"/>
+                </a:solidFill>
+              </a:rPr>
+              <a:t>Repositório no GitHub</a:t>
+            </a:r>
+          </a:p>
+        </p:txBody>
+      </p:sp>
+      <p:pic>
+        <p:nvPicPr>
+          <p:cNvPr id="1030" name="Picture 6" descr="Google Colab - Wikipedia">
+            <a:extLst>
+              <a:ext uri="{FF2B5EF4-FFF2-40B4-BE49-F238E27FC236}">
+                <a16:creationId xmlns:a16="http://schemas.microsoft.com/office/drawing/2014/main" id="{232497C8-95D1-AAEA-1C43-E77A24B2F966}"/>
+              </a:ext>
+            </a:extLst>
+          </p:cNvPr>
+          <p:cNvPicPr>
+            <a:picLocks noChangeAspect="1" noChangeArrowheads="1"/>
+          </p:cNvPicPr>
+          <p:nvPr/>
+        </p:nvPicPr>
+        <p:blipFill>
+          <a:blip r:embed="rId6">
+            <a:extLst>
+              <a:ext uri="{28A0092B-C50C-407E-A947-70E740481C1C}">
+                <a14:useLocalDpi xmlns:a14="http://schemas.microsoft.com/office/drawing/2010/main" val="0"/>
+              </a:ext>
+            </a:extLst>
+          </a:blip>
+          <a:srcRect/>
+          <a:stretch>
+            <a:fillRect/>
+          </a:stretch>
+        </p:blipFill>
+        <p:spPr bwMode="auto">
+          <a:xfrm>
+            <a:off x="1089764" y="2865942"/>
+            <a:ext cx="927800" cy="530874"/>
+          </a:xfrm>
+          <a:prstGeom prst="rect">
+            <a:avLst/>
+          </a:prstGeom>
+          <a:noFill/>
+          <a:extLst>
+            <a:ext uri="{909E8E84-426E-40DD-AFC4-6F175D3DCCD1}">
+              <a14:hiddenFill xmlns:a14="http://schemas.microsoft.com/office/drawing/2010/main">
+                <a:solidFill>
+                  <a:srgbClr val="FFFFFF"/>
+                </a:solidFill>
+              </a14:hiddenFill>
+            </a:ext>
+          </a:extLst>
+        </p:spPr>
+      </p:pic>
+      <p:sp>
+        <p:nvSpPr>
+          <p:cNvPr id="13" name="CaixaDeTexto 12">
+            <a:extLst>
+              <a:ext uri="{FF2B5EF4-FFF2-40B4-BE49-F238E27FC236}">
+                <a16:creationId xmlns:a16="http://schemas.microsoft.com/office/drawing/2014/main" id="{72ECCE7C-697B-0EE9-39ED-DF7163F8A650}"/>
+              </a:ext>
+            </a:extLst>
+          </p:cNvPr>
+          <p:cNvSpPr txBox="1"/>
+          <p:nvPr/>
+        </p:nvSpPr>
+        <p:spPr>
+          <a:xfrm>
+            <a:off x="2198112" y="4975068"/>
+            <a:ext cx="8211099" cy="584775"/>
+          </a:xfrm>
+          <a:prstGeom prst="rect">
+            <a:avLst/>
+          </a:prstGeom>
+          <a:noFill/>
+        </p:spPr>
+        <p:txBody>
+          <a:bodyPr wrap="square" rtlCol="0">
+            <a:spAutoFit/>
+          </a:bodyPr>
+          <a:lstStyle/>
+          <a:p>
+            <a:r>
+              <a:rPr lang="pt-BR" sz="1600" dirty="0">
+                <a:solidFill>
+                  <a:schemeClr val="bg1"/>
+                </a:solidFill>
+                <a:hlinkClick r:id="rId7">
+                  <a:extLst>
+                    <a:ext uri="{A12FA001-AC4F-418D-AE19-62706E023703}">
+                      <ahyp:hlinkClr xmlns:ahyp="http://schemas.microsoft.com/office/drawing/2018/hyperlinkcolor" val="tx"/>
+                    </a:ext>
+                  </a:extLst>
+                </a:hlinkClick>
+              </a:rPr>
+              <a:t>https://colab.research.google.com/drive/1C309HgnrJvy2qbz-orDNf-rBpmrckQIs#scrollTo=YQB_48cyujav</a:t>
+            </a:r>
+            <a:endParaRPr lang="pt-BR" sz="1600" dirty="0">
+              <a:solidFill>
+                <a:schemeClr val="bg1"/>
+              </a:solidFill>
+            </a:endParaRPr>
+          </a:p>
+        </p:txBody>
+      </p:sp>
+      <p:sp>
+        <p:nvSpPr>
+          <p:cNvPr id="14" name="CaixaDeTexto 13">
+            <a:extLst>
+              <a:ext uri="{FF2B5EF4-FFF2-40B4-BE49-F238E27FC236}">
+                <a16:creationId xmlns:a16="http://schemas.microsoft.com/office/drawing/2014/main" id="{77ED5148-E4F1-995B-7CB8-8188EC552C81}"/>
+              </a:ext>
+            </a:extLst>
+          </p:cNvPr>
+          <p:cNvSpPr txBox="1"/>
+          <p:nvPr/>
+        </p:nvSpPr>
+        <p:spPr>
+          <a:xfrm>
+            <a:off x="2198113" y="4639074"/>
+            <a:ext cx="4532672" cy="400110"/>
+          </a:xfrm>
+          <a:prstGeom prst="rect">
+            <a:avLst/>
+          </a:prstGeom>
+          <a:noFill/>
+        </p:spPr>
+        <p:txBody>
+          <a:bodyPr wrap="square" rtlCol="0">
+            <a:spAutoFit/>
+          </a:bodyPr>
+          <a:lstStyle/>
+          <a:p>
+            <a:r>
+              <a:rPr lang="pt-BR" sz="2000" b="1" dirty="0">
+                <a:solidFill>
+                  <a:schemeClr val="bg1"/>
+                </a:solidFill>
+              </a:rPr>
+              <a:t>Fine-</a:t>
+            </a:r>
+            <a:r>
+              <a:rPr lang="pt-BR" sz="2000" b="1" dirty="0" err="1">
+                <a:solidFill>
+                  <a:schemeClr val="bg1"/>
+                </a:solidFill>
+              </a:rPr>
+              <a:t>tuning</a:t>
+            </a:r>
+            <a:endParaRPr lang="pt-BR" sz="2000" b="1" dirty="0">
+              <a:solidFill>
+                <a:schemeClr val="bg1"/>
+              </a:solidFill>
+            </a:endParaRPr>
+          </a:p>
+        </p:txBody>
+      </p:sp>
+      <p:sp>
+        <p:nvSpPr>
+          <p:cNvPr id="15" name="CaixaDeTexto 14">
+            <a:extLst>
+              <a:ext uri="{FF2B5EF4-FFF2-40B4-BE49-F238E27FC236}">
+                <a16:creationId xmlns:a16="http://schemas.microsoft.com/office/drawing/2014/main" id="{5E3C8A85-30F7-17B6-76A4-A74415F242EF}"/>
+              </a:ext>
+            </a:extLst>
+          </p:cNvPr>
+          <p:cNvSpPr txBox="1"/>
+          <p:nvPr/>
+        </p:nvSpPr>
+        <p:spPr>
+          <a:xfrm>
+            <a:off x="2880853" y="3131379"/>
+            <a:ext cx="7777314" cy="769441"/>
+          </a:xfrm>
+          <a:prstGeom prst="rect">
+            <a:avLst/>
+          </a:prstGeom>
+          <a:noFill/>
+        </p:spPr>
+        <p:txBody>
+          <a:bodyPr wrap="square" rtlCol="0">
+            <a:spAutoFit/>
+          </a:bodyPr>
+          <a:lstStyle/>
+          <a:p>
+            <a:r>
+              <a:rPr lang="pt-BR" sz="1200" i="1" dirty="0">
+                <a:solidFill>
+                  <a:schemeClr val="bg1"/>
+                </a:solidFill>
+              </a:rPr>
+              <a:t>Gerar perguntas e respostas</a:t>
+            </a:r>
+            <a:endParaRPr lang="pt-BR" sz="1200" i="1" dirty="0">
+              <a:solidFill>
+                <a:schemeClr val="bg1"/>
+              </a:solidFill>
+              <a:hlinkClick r:id="rId8">
+                <a:extLst>
+                  <a:ext uri="{A12FA001-AC4F-418D-AE19-62706E023703}">
+                    <ahyp:hlinkClr xmlns:ahyp="http://schemas.microsoft.com/office/drawing/2018/hyperlinkcolor" val="tx"/>
+                  </a:ext>
+                </a:extLst>
+              </a:hlinkClick>
+            </a:endParaRPr>
+          </a:p>
+          <a:p>
+            <a:r>
+              <a:rPr lang="pt-BR" sz="1600" dirty="0">
+                <a:solidFill>
+                  <a:schemeClr val="bg1"/>
+                </a:solidFill>
+                <a:hlinkClick r:id="rId8">
+                  <a:extLst>
+                    <a:ext uri="{A12FA001-AC4F-418D-AE19-62706E023703}">
+                      <ahyp:hlinkClr xmlns:ahyp="http://schemas.microsoft.com/office/drawing/2018/hyperlinkcolor" val="tx"/>
+                    </a:ext>
+                  </a:extLst>
+                </a:hlinkClick>
+              </a:rPr>
+              <a:t>https://colab.research.google.com/drive/1dN2PjqS9AaOxODwnwlkaclZfVnfs5XoQ#scrollTo=-HSgxS06x8kE</a:t>
+            </a:r>
+            <a:endParaRPr lang="pt-BR" sz="1600" dirty="0">
+              <a:solidFill>
+                <a:schemeClr val="bg1"/>
+              </a:solidFill>
+            </a:endParaRPr>
+          </a:p>
+        </p:txBody>
+      </p:sp>
+      <p:sp>
+        <p:nvSpPr>
+          <p:cNvPr id="17" name="CaixaDeTexto 16">
+            <a:extLst>
+              <a:ext uri="{FF2B5EF4-FFF2-40B4-BE49-F238E27FC236}">
+                <a16:creationId xmlns:a16="http://schemas.microsoft.com/office/drawing/2014/main" id="{B143E158-962B-DE56-1AE6-30EA32004C06}"/>
+              </a:ext>
+            </a:extLst>
+          </p:cNvPr>
+          <p:cNvSpPr txBox="1"/>
+          <p:nvPr/>
+        </p:nvSpPr>
+        <p:spPr>
+          <a:xfrm>
+            <a:off x="2198113" y="2795385"/>
+            <a:ext cx="4781627" cy="400110"/>
+          </a:xfrm>
+          <a:prstGeom prst="rect">
+            <a:avLst/>
+          </a:prstGeom>
+          <a:noFill/>
+        </p:spPr>
+        <p:txBody>
+          <a:bodyPr wrap="square" rtlCol="0">
+            <a:spAutoFit/>
+          </a:bodyPr>
+          <a:lstStyle/>
+          <a:p>
+            <a:r>
+              <a:rPr lang="pt-BR" sz="2000" b="1" dirty="0">
+                <a:solidFill>
+                  <a:schemeClr val="bg1"/>
+                </a:solidFill>
+              </a:rPr>
+              <a:t>Teste RAG com ChatGPT</a:t>
+            </a:r>
+          </a:p>
+        </p:txBody>
+      </p:sp>
+      <p:sp>
+        <p:nvSpPr>
+          <p:cNvPr id="22" name="CaixaDeTexto 21">
+            <a:extLst>
+              <a:ext uri="{FF2B5EF4-FFF2-40B4-BE49-F238E27FC236}">
+                <a16:creationId xmlns:a16="http://schemas.microsoft.com/office/drawing/2014/main" id="{0B3DBDF2-0882-426B-C999-8C9A0A477C24}"/>
+              </a:ext>
+            </a:extLst>
+          </p:cNvPr>
+          <p:cNvSpPr txBox="1"/>
+          <p:nvPr/>
+        </p:nvSpPr>
+        <p:spPr>
+          <a:xfrm>
+            <a:off x="2880852" y="3937502"/>
+            <a:ext cx="7777314" cy="523220"/>
+          </a:xfrm>
+          <a:prstGeom prst="rect">
+            <a:avLst/>
+          </a:prstGeom>
+          <a:noFill/>
+        </p:spPr>
+        <p:txBody>
+          <a:bodyPr wrap="square" rtlCol="0">
+            <a:spAutoFit/>
+          </a:bodyPr>
+          <a:lstStyle/>
+          <a:p>
+            <a:r>
+              <a:rPr lang="pt-BR" sz="1200" i="1" dirty="0">
+                <a:solidFill>
+                  <a:schemeClr val="bg1"/>
+                </a:solidFill>
+              </a:rPr>
+              <a:t>Avaliar as respostas</a:t>
+            </a:r>
+          </a:p>
+          <a:p>
+            <a:r>
+              <a:rPr lang="pt-BR" sz="1600" dirty="0">
+                <a:solidFill>
+                  <a:schemeClr val="bg1"/>
+                </a:solidFill>
+                <a:hlinkClick r:id="rId9"/>
+              </a:rPr>
+              <a:t>https://colab.research.google.com/drive/1DGdPI1DVv_1XXBsAKF6yVmABE8FCy8O7</a:t>
+            </a:r>
+            <a:endParaRPr lang="pt-BR" sz="1600" dirty="0">
+              <a:solidFill>
+                <a:schemeClr val="bg1"/>
+              </a:solidFill>
+            </a:endParaRPr>
+          </a:p>
+        </p:txBody>
+      </p:sp>
+    </p:spTree>
+    <p:extLst>
+      <p:ext uri="{BB962C8B-B14F-4D97-AF65-F5344CB8AC3E}">
+        <p14:creationId xmlns:p14="http://schemas.microsoft.com/office/powerpoint/2010/main" val="1451813650"/>
       </p:ext>
     </p:extLst>
   </p:cSld>

</xml_diff>